<commit_message>
Updated cheatsheet to 17 slides with GitHub nav and workflow summary
</commit_message>
<xml_diff>
--- a/MaiaEdge_Toolkit_Cheatsheet.pptx
+++ b/MaiaEdge_Toolkit_Cheatsheet.pptx
@@ -21,9 +21,10 @@
     <p:sldId id="269" r:id="rId15"/>
     <p:sldId id="270" r:id="rId16"/>
     <p:sldId id="271" r:id="rId17"/>
+    <p:sldId id="272" r:id="rId18"/>
   </p:sldIdLst>
   <p:notesMasterIdLst>
-    <p:notesMasterId r:id="rId18"/>
+    <p:notesMasterId r:id="rId19"/>
   </p:notesMasterIdLst>
   <p:sldSz cx="9144000" cy="5143500"/>
   <p:notesSz cx="5143500" cy="9144000"/>
@@ -1157,6 +1158,94 @@
             <a:fld id="{F7021451-1387-4CA6-816F-3879F97B5CBC}" type="slidenum">
               <a:rPr lang="en-US"/>
               <a:t>16</a:t>
+            </a:fld>
+            <a:endParaRPr lang="en-US"/>
+          </a:p>
+        </p:txBody>
+      </p:sp>
+    </p:spTree>
+    <p:extLst>
+      <p:ext uri="{BB962C8B-B14F-4D97-AF65-F5344CB8AC3E}">
+        <p14:creationId xmlns:p14="http://schemas.microsoft.com/office/powerpoint/2010/main" val="1024086991"/>
+      </p:ext>
+    </p:extLst>
+  </p:cSld>
+  <p:clrMapOvr>
+    <a:masterClrMapping/>
+  </p:clrMapOvr>
+</p:notes>
+</file>
+
+<file path=ppt/notesSlides/notesSlide17.xml><?xml version="1.0" encoding="utf-8"?>
+<p:notes xmlns:a="http://schemas.openxmlformats.org/drawingml/2006/main" xmlns:r="http://schemas.openxmlformats.org/officeDocument/2006/relationships" xmlns:p="http://schemas.openxmlformats.org/presentationml/2006/main">
+  <p:cSld>
+    <p:spTree>
+      <p:nvGrpSpPr>
+        <p:cNvPr id="1" name=""/>
+        <p:cNvGrpSpPr/>
+        <p:nvPr/>
+      </p:nvGrpSpPr>
+      <p:grpSpPr>
+        <a:xfrm>
+          <a:off x="0" y="0"/>
+          <a:ext cx="0" cy="0"/>
+          <a:chOff x="0" y="0"/>
+          <a:chExt cx="0" cy="0"/>
+        </a:xfrm>
+      </p:grpSpPr>
+      <p:sp>
+        <p:nvSpPr>
+          <p:cNvPr id="2" name="Slide Image Placeholder 1"/>
+          <p:cNvSpPr>
+            <a:spLocks noGrp="1" noRot="1" noChangeAspect="1"/>
+          </p:cNvSpPr>
+          <p:nvPr>
+            <p:ph type="sldImg"/>
+          </p:nvPr>
+        </p:nvSpPr>
+        <p:spPr/>
+      </p:sp>
+      <p:sp>
+        <p:nvSpPr>
+          <p:cNvPr id="3" name="Notes Placeholder 2"/>
+          <p:cNvSpPr>
+            <a:spLocks noGrp="1"/>
+          </p:cNvSpPr>
+          <p:nvPr>
+            <p:ph type="body" idx="1"/>
+          </p:nvPr>
+        </p:nvSpPr>
+        <p:spPr/>
+        <p:txBody>
+          <a:bodyPr/>
+          <a:lstStyle/>
+          <a:p>
+            <a:r>
+              <a:rPr lang="en-US" dirty="0"/>
+              <a:t/>
+            </a:r>
+            <a:endParaRPr lang="en-US" dirty="0"/>
+          </a:p>
+        </p:txBody>
+      </p:sp>
+      <p:sp>
+        <p:nvSpPr>
+          <p:cNvPr id="4" name="Slide Number Placeholder 3"/>
+          <p:cNvSpPr>
+            <a:spLocks noGrp="1"/>
+          </p:cNvSpPr>
+          <p:nvPr>
+            <p:ph type="sldNum" sz="quarter" idx="10"/>
+          </p:nvPr>
+        </p:nvSpPr>
+        <p:spPr/>
+        <p:txBody>
+          <a:bodyPr/>
+          <a:lstStyle/>
+          <a:p>
+            <a:fld id="{F7021451-1387-4CA6-816F-3879F97B5CBC}" type="slidenum">
+              <a:rPr lang="en-US"/>
+              <a:t>17</a:t>
             </a:fld>
             <a:endParaRPr lang="en-US"/>
           </a:p>
@@ -11207,6 +11296,936 @@
 </p:sld>
 </file>
 
+<file path=ppt/slides/slide17.xml><?xml version="1.0" encoding="utf-8"?>
+<p:sld xmlns:a="http://schemas.openxmlformats.org/drawingml/2006/main" xmlns:r="http://schemas.openxmlformats.org/officeDocument/2006/relationships" xmlns:p="http://schemas.openxmlformats.org/presentationml/2006/main">
+  <p:cSld name="Slide 17">
+    <p:bg>
+      <p:bgPr>
+        <a:solidFill>
+          <a:srgbClr val="0F1B2D"/>
+        </a:solidFill>
+      </p:bgPr>
+    </p:bg>
+    <p:spTree>
+      <p:nvGrpSpPr>
+        <p:cNvPr id="1" name=""/>
+        <p:cNvGrpSpPr/>
+        <p:nvPr/>
+      </p:nvGrpSpPr>
+      <p:grpSpPr>
+        <a:xfrm>
+          <a:off x="0" y="0"/>
+          <a:ext cx="0" cy="0"/>
+          <a:chOff x="0" y="0"/>
+          <a:chExt cx="0" cy="0"/>
+        </a:xfrm>
+      </p:grpSpPr>
+      <p:sp>
+        <p:nvSpPr>
+          <p:cNvPr id="2" name="Shape 0"/>
+          <p:cNvSpPr/>
+          <p:nvPr/>
+        </p:nvSpPr>
+        <p:spPr>
+          <a:xfrm>
+            <a:off x="0" y="0"/>
+            <a:ext cx="9144000" cy="54864"/>
+          </a:xfrm>
+          <a:prstGeom prst="rect">
+            <a:avLst/>
+          </a:prstGeom>
+          <a:solidFill>
+            <a:srgbClr val="2196F3"/>
+          </a:solidFill>
+          <a:ln/>
+        </p:spPr>
+      </p:sp>
+      <p:sp>
+        <p:nvSpPr>
+          <p:cNvPr id="3" name="Text 1"/>
+          <p:cNvSpPr/>
+          <p:nvPr/>
+        </p:nvSpPr>
+        <p:spPr>
+          <a:xfrm>
+            <a:off x="731520" y="182880"/>
+            <a:ext cx="7680960" cy="457200"/>
+          </a:xfrm>
+          <a:prstGeom prst="rect">
+            <a:avLst/>
+          </a:prstGeom>
+          <a:noFill/>
+          <a:ln/>
+        </p:spPr>
+        <p:txBody>
+          <a:bodyPr wrap="square" rtlCol="0" anchor="ctr"/>
+          <a:lstStyle/>
+          <a:p>
+            <a:pPr indent="0" marL="0">
+              <a:buNone/>
+            </a:pPr>
+            <a:r>
+              <a:rPr lang="en-US" sz="3600" b="1" dirty="0">
+                <a:solidFill>
+                  <a:srgbClr val="FFFFFF"/>
+                </a:solidFill>
+                <a:latin typeface="Arial Black" pitchFamily="34" charset="0"/>
+                <a:ea typeface="Arial Black" pitchFamily="34" charset="-122"/>
+                <a:cs typeface="Arial Black" pitchFamily="34" charset="-120"/>
+              </a:rPr>
+              <a:t>From Now On</a:t>
+            </a:r>
+            <a:endParaRPr lang="en-US" sz="3600" dirty="0"/>
+          </a:p>
+        </p:txBody>
+      </p:sp>
+      <p:sp>
+        <p:nvSpPr>
+          <p:cNvPr id="4" name="Text 2"/>
+          <p:cNvSpPr/>
+          <p:nvPr/>
+        </p:nvSpPr>
+        <p:spPr>
+          <a:xfrm>
+            <a:off x="731520" y="594360"/>
+            <a:ext cx="7680960" cy="274320"/>
+          </a:xfrm>
+          <a:prstGeom prst="rect">
+            <a:avLst/>
+          </a:prstGeom>
+          <a:noFill/>
+          <a:ln/>
+        </p:spPr>
+        <p:txBody>
+          <a:bodyPr wrap="square" rtlCol="0" anchor="ctr"/>
+          <a:lstStyle/>
+          <a:p>
+            <a:pPr indent="0" marL="0">
+              <a:buNone/>
+            </a:pPr>
+            <a:r>
+              <a:rPr lang="en-US" sz="1400" i="1" dirty="0">
+                <a:solidFill>
+                  <a:srgbClr val="B0BEC5"/>
+                </a:solidFill>
+                <a:latin typeface="Arial" pitchFamily="34" charset="0"/>
+                <a:ea typeface="Arial" pitchFamily="34" charset="-122"/>
+                <a:cs typeface="Arial" pitchFamily="34" charset="-120"/>
+              </a:rPr>
+              <a:t>This is your entire workflow going forward.</a:t>
+            </a:r>
+            <a:endParaRPr lang="en-US" sz="1400" dirty="0"/>
+          </a:p>
+        </p:txBody>
+      </p:sp>
+      <p:sp>
+        <p:nvSpPr>
+          <p:cNvPr id="5" name="Shape 3"/>
+          <p:cNvSpPr/>
+          <p:nvPr/>
+        </p:nvSpPr>
+        <p:spPr>
+          <a:xfrm>
+            <a:off x="457200" y="1051560"/>
+            <a:ext cx="8321040" cy="1097280"/>
+          </a:xfrm>
+          <a:prstGeom prst="rect">
+            <a:avLst/>
+          </a:prstGeom>
+          <a:solidFill>
+            <a:srgbClr val="1E2D3D"/>
+          </a:solidFill>
+          <a:ln/>
+          <a:effectLst>
+            <a:outerShdw sx="100000" sy="100000" kx="0" ky="0" algn="bl" rotWithShape="0" blurRad="50800" dist="25400" dir="8100000">
+              <a:srgbClr val="000000">
+                <a:alpha val="30000"/>
+              </a:srgbClr>
+            </a:outerShdw>
+          </a:effectLst>
+        </p:spPr>
+      </p:sp>
+      <p:sp>
+        <p:nvSpPr>
+          <p:cNvPr id="6" name="Shape 4"/>
+          <p:cNvSpPr/>
+          <p:nvPr/>
+        </p:nvSpPr>
+        <p:spPr>
+          <a:xfrm>
+            <a:off x="457200" y="1051560"/>
+            <a:ext cx="54864" cy="1097280"/>
+          </a:xfrm>
+          <a:prstGeom prst="rect">
+            <a:avLst/>
+          </a:prstGeom>
+          <a:solidFill>
+            <a:srgbClr val="64B5F6"/>
+          </a:solidFill>
+          <a:ln/>
+        </p:spPr>
+      </p:sp>
+      <p:sp>
+        <p:nvSpPr>
+          <p:cNvPr id="7" name="Shape 5"/>
+          <p:cNvSpPr/>
+          <p:nvPr/>
+        </p:nvSpPr>
+        <p:spPr>
+          <a:xfrm>
+            <a:off x="731520" y="1188720"/>
+            <a:ext cx="457200" cy="457200"/>
+          </a:xfrm>
+          <a:prstGeom prst="ellipse">
+            <a:avLst/>
+          </a:prstGeom>
+          <a:solidFill>
+            <a:srgbClr val="64B5F6"/>
+          </a:solidFill>
+          <a:ln/>
+        </p:spPr>
+      </p:sp>
+      <p:sp>
+        <p:nvSpPr>
+          <p:cNvPr id="8" name="Text 6"/>
+          <p:cNvSpPr/>
+          <p:nvPr/>
+        </p:nvSpPr>
+        <p:spPr>
+          <a:xfrm>
+            <a:off x="731520" y="1188720"/>
+            <a:ext cx="457200" cy="457200"/>
+          </a:xfrm>
+          <a:prstGeom prst="rect">
+            <a:avLst/>
+          </a:prstGeom>
+          <a:noFill/>
+          <a:ln/>
+        </p:spPr>
+        <p:txBody>
+          <a:bodyPr wrap="square" rtlCol="0" anchor="ctr"/>
+          <a:lstStyle/>
+          <a:p>
+            <a:pPr algn="ctr" indent="0" marL="0">
+              <a:buNone/>
+            </a:pPr>
+            <a:r>
+              <a:rPr lang="en-US" sz="2200" dirty="0">
+                <a:solidFill>
+                  <a:srgbClr val="0F1B2D"/>
+                </a:solidFill>
+                <a:latin typeface="Arial Black" pitchFamily="34" charset="0"/>
+                <a:ea typeface="Arial Black" pitchFamily="34" charset="-122"/>
+                <a:cs typeface="Arial Black" pitchFamily="34" charset="-120"/>
+              </a:rPr>
+              <a:t>1</a:t>
+            </a:r>
+            <a:endParaRPr lang="en-US" sz="2200" dirty="0"/>
+          </a:p>
+        </p:txBody>
+      </p:sp>
+      <p:sp>
+        <p:nvSpPr>
+          <p:cNvPr id="9" name="Text 7"/>
+          <p:cNvSpPr/>
+          <p:nvPr/>
+        </p:nvSpPr>
+        <p:spPr>
+          <a:xfrm>
+            <a:off x="1371600" y="1143000"/>
+            <a:ext cx="7132320" cy="320040"/>
+          </a:xfrm>
+          <a:prstGeom prst="rect">
+            <a:avLst/>
+          </a:prstGeom>
+          <a:noFill/>
+          <a:ln/>
+        </p:spPr>
+        <p:txBody>
+          <a:bodyPr wrap="square" lIns="0" tIns="0" rIns="0" bIns="0" rtlCol="0" anchor="ctr"/>
+          <a:lstStyle/>
+          <a:p>
+            <a:pPr indent="0" marL="0">
+              <a:buNone/>
+            </a:pPr>
+            <a:r>
+              <a:rPr lang="en-US" sz="1600" b="1" dirty="0">
+                <a:solidFill>
+                  <a:srgbClr val="FFFFFF"/>
+                </a:solidFill>
+                <a:latin typeface="Arial" pitchFamily="34" charset="0"/>
+                <a:ea typeface="Arial" pitchFamily="34" charset="-122"/>
+                <a:cs typeface="Arial" pitchFamily="34" charset="-120"/>
+              </a:rPr>
+              <a:t>Tell Claude Code what to change</a:t>
+            </a:r>
+            <a:endParaRPr lang="en-US" sz="1600" dirty="0"/>
+          </a:p>
+        </p:txBody>
+      </p:sp>
+      <p:sp>
+        <p:nvSpPr>
+          <p:cNvPr id="10" name="Text 8"/>
+          <p:cNvSpPr/>
+          <p:nvPr/>
+        </p:nvSpPr>
+        <p:spPr>
+          <a:xfrm>
+            <a:off x="1371600" y="1463040"/>
+            <a:ext cx="7132320" cy="539496"/>
+          </a:xfrm>
+          <a:prstGeom prst="rect">
+            <a:avLst/>
+          </a:prstGeom>
+          <a:noFill/>
+          <a:ln/>
+        </p:spPr>
+        <p:txBody>
+          <a:bodyPr wrap="square" lIns="0" tIns="0" rIns="0" bIns="0" rtlCol="0" anchor="ctr"/>
+          <a:lstStyle/>
+          <a:p>
+            <a:pPr indent="0" marL="0">
+              <a:buNone/>
+            </a:pPr>
+            <a:r>
+              <a:rPr lang="en-US" sz="1000" i="1" dirty="0">
+                <a:solidFill>
+                  <a:srgbClr val="64B5F6"/>
+                </a:solidFill>
+                <a:latin typeface="Arial" pitchFamily="34" charset="0"/>
+                <a:ea typeface="Arial" pitchFamily="34" charset="-122"/>
+                <a:cs typeface="Arial" pitchFamily="34" charset="-120"/>
+              </a:rPr>
+              <a:t>"Update the neocloud strategy with this new intel"</a:t>
+            </a:r>
+            <a:endParaRPr lang="en-US" sz="1000" dirty="0"/>
+          </a:p>
+          <a:p>
+            <a:pPr indent="0" marL="0">
+              <a:buNone/>
+            </a:pPr>
+            <a:r>
+              <a:rPr lang="en-US" sz="1000" i="1" dirty="0">
+                <a:solidFill>
+                  <a:srgbClr val="64B5F6"/>
+                </a:solidFill>
+                <a:latin typeface="Arial" pitchFamily="34" charset="0"/>
+                <a:ea typeface="Arial" pitchFamily="34" charset="-122"/>
+                <a:cs typeface="Arial" pitchFamily="34" charset="-120"/>
+              </a:rPr>
+              <a:t>"Fix the SDR pipeline skill to stop using credibility anchors"</a:t>
+            </a:r>
+            <a:endParaRPr lang="en-US" sz="1000" dirty="0"/>
+          </a:p>
+          <a:p>
+            <a:pPr indent="0" marL="0">
+              <a:buNone/>
+            </a:pPr>
+            <a:r>
+              <a:rPr lang="en-US" sz="1000" i="1" dirty="0">
+                <a:solidFill>
+                  <a:srgbClr val="64B5F6"/>
+                </a:solidFill>
+                <a:latin typeface="Arial" pitchFamily="34" charset="0"/>
+                <a:ea typeface="Arial" pitchFamily="34" charset="-122"/>
+                <a:cs typeface="Arial" pitchFamily="34" charset="-120"/>
+              </a:rPr>
+              <a:t>"Add a new discovery-prep skill"</a:t>
+            </a:r>
+            <a:endParaRPr lang="en-US" sz="1000" dirty="0"/>
+          </a:p>
+        </p:txBody>
+      </p:sp>
+      <p:sp>
+        <p:nvSpPr>
+          <p:cNvPr id="11" name="Text 9"/>
+          <p:cNvSpPr/>
+          <p:nvPr/>
+        </p:nvSpPr>
+        <p:spPr>
+          <a:xfrm>
+            <a:off x="1371600" y="2002536"/>
+            <a:ext cx="7132320" cy="320040"/>
+          </a:xfrm>
+          <a:prstGeom prst="rect">
+            <a:avLst/>
+          </a:prstGeom>
+          <a:noFill/>
+          <a:ln/>
+        </p:spPr>
+        <p:txBody>
+          <a:bodyPr wrap="square" lIns="0" tIns="0" rIns="0" bIns="0" rtlCol="0" anchor="ctr"/>
+          <a:lstStyle/>
+          <a:p>
+            <a:pPr indent="0" marL="0">
+              <a:buNone/>
+            </a:pPr>
+            <a:r>
+              <a:rPr lang="en-US" sz="1000" dirty="0">
+                <a:solidFill>
+                  <a:srgbClr val="B0BEC5"/>
+                </a:solidFill>
+                <a:latin typeface="Arial" pitchFamily="34" charset="0"/>
+                <a:ea typeface="Arial" pitchFamily="34" charset="-122"/>
+                <a:cs typeface="Arial" pitchFamily="34" charset="-120"/>
+              </a:rPr>
+              <a:t>Claude edits the source files in context/ or skills/ directly. Changes take effect in Claude Code immediately.</a:t>
+            </a:r>
+            <a:endParaRPr lang="en-US" sz="1000" dirty="0"/>
+          </a:p>
+        </p:txBody>
+      </p:sp>
+      <p:sp>
+        <p:nvSpPr>
+          <p:cNvPr id="12" name="Shape 10"/>
+          <p:cNvSpPr/>
+          <p:nvPr/>
+        </p:nvSpPr>
+        <p:spPr>
+          <a:xfrm>
+            <a:off x="457200" y="2286000"/>
+            <a:ext cx="8321040" cy="914400"/>
+          </a:xfrm>
+          <a:prstGeom prst="rect">
+            <a:avLst/>
+          </a:prstGeom>
+          <a:solidFill>
+            <a:srgbClr val="1E2D3D"/>
+          </a:solidFill>
+          <a:ln/>
+          <a:effectLst>
+            <a:outerShdw sx="100000" sy="100000" kx="0" ky="0" algn="bl" rotWithShape="0" blurRad="50800" dist="25400" dir="8100000">
+              <a:srgbClr val="000000">
+                <a:alpha val="30000"/>
+              </a:srgbClr>
+            </a:outerShdw>
+          </a:effectLst>
+        </p:spPr>
+      </p:sp>
+      <p:sp>
+        <p:nvSpPr>
+          <p:cNvPr id="13" name="Shape 11"/>
+          <p:cNvSpPr/>
+          <p:nvPr/>
+        </p:nvSpPr>
+        <p:spPr>
+          <a:xfrm>
+            <a:off x="457200" y="2286000"/>
+            <a:ext cx="54864" cy="914400"/>
+          </a:xfrm>
+          <a:prstGeom prst="rect">
+            <a:avLst/>
+          </a:prstGeom>
+          <a:solidFill>
+            <a:srgbClr val="00BCD4"/>
+          </a:solidFill>
+          <a:ln/>
+        </p:spPr>
+      </p:sp>
+      <p:sp>
+        <p:nvSpPr>
+          <p:cNvPr id="14" name="Shape 12"/>
+          <p:cNvSpPr/>
+          <p:nvPr/>
+        </p:nvSpPr>
+        <p:spPr>
+          <a:xfrm>
+            <a:off x="731520" y="2423160"/>
+            <a:ext cx="457200" cy="457200"/>
+          </a:xfrm>
+          <a:prstGeom prst="ellipse">
+            <a:avLst/>
+          </a:prstGeom>
+          <a:solidFill>
+            <a:srgbClr val="00BCD4"/>
+          </a:solidFill>
+          <a:ln/>
+        </p:spPr>
+      </p:sp>
+      <p:sp>
+        <p:nvSpPr>
+          <p:cNvPr id="15" name="Text 13"/>
+          <p:cNvSpPr/>
+          <p:nvPr/>
+        </p:nvSpPr>
+        <p:spPr>
+          <a:xfrm>
+            <a:off x="731520" y="2423160"/>
+            <a:ext cx="457200" cy="457200"/>
+          </a:xfrm>
+          <a:prstGeom prst="rect">
+            <a:avLst/>
+          </a:prstGeom>
+          <a:noFill/>
+          <a:ln/>
+        </p:spPr>
+        <p:txBody>
+          <a:bodyPr wrap="square" rtlCol="0" anchor="ctr"/>
+          <a:lstStyle/>
+          <a:p>
+            <a:pPr algn="ctr" indent="0" marL="0">
+              <a:buNone/>
+            </a:pPr>
+            <a:r>
+              <a:rPr lang="en-US" sz="2200" dirty="0">
+                <a:solidFill>
+                  <a:srgbClr val="0F1B2D"/>
+                </a:solidFill>
+                <a:latin typeface="Arial Black" pitchFamily="34" charset="0"/>
+                <a:ea typeface="Arial Black" pitchFamily="34" charset="-122"/>
+                <a:cs typeface="Arial Black" pitchFamily="34" charset="-120"/>
+              </a:rPr>
+              <a:t>2</a:t>
+            </a:r>
+            <a:endParaRPr lang="en-US" sz="2200" dirty="0"/>
+          </a:p>
+        </p:txBody>
+      </p:sp>
+      <p:sp>
+        <p:nvSpPr>
+          <p:cNvPr id="16" name="Text 14"/>
+          <p:cNvSpPr/>
+          <p:nvPr/>
+        </p:nvSpPr>
+        <p:spPr>
+          <a:xfrm>
+            <a:off x="1371600" y="2377440"/>
+            <a:ext cx="7132320" cy="320040"/>
+          </a:xfrm>
+          <a:prstGeom prst="rect">
+            <a:avLst/>
+          </a:prstGeom>
+          <a:noFill/>
+          <a:ln/>
+        </p:spPr>
+        <p:txBody>
+          <a:bodyPr wrap="square" lIns="0" tIns="0" rIns="0" bIns="0" rtlCol="0" anchor="ctr"/>
+          <a:lstStyle/>
+          <a:p>
+            <a:pPr indent="0" marL="0">
+              <a:buNone/>
+            </a:pPr>
+            <a:r>
+              <a:rPr lang="en-US" sz="1600" b="1" dirty="0">
+                <a:solidFill>
+                  <a:srgbClr val="FFFFFF"/>
+                </a:solidFill>
+                <a:latin typeface="Arial" pitchFamily="34" charset="0"/>
+                <a:ea typeface="Arial" pitchFamily="34" charset="-122"/>
+                <a:cs typeface="Arial" pitchFamily="34" charset="-120"/>
+              </a:rPr>
+              <a:t>Tell Claude Code to rebuild and push</a:t>
+            </a:r>
+            <a:endParaRPr lang="en-US" sz="1600" dirty="0"/>
+          </a:p>
+        </p:txBody>
+      </p:sp>
+      <p:sp>
+        <p:nvSpPr>
+          <p:cNvPr id="17" name="Text 15"/>
+          <p:cNvSpPr/>
+          <p:nvPr/>
+        </p:nvSpPr>
+        <p:spPr>
+          <a:xfrm>
+            <a:off x="1371600" y="2697480"/>
+            <a:ext cx="7132320" cy="210312"/>
+          </a:xfrm>
+          <a:prstGeom prst="rect">
+            <a:avLst/>
+          </a:prstGeom>
+          <a:noFill/>
+          <a:ln/>
+        </p:spPr>
+        <p:txBody>
+          <a:bodyPr wrap="square" lIns="0" tIns="0" rIns="0" bIns="0" rtlCol="0" anchor="ctr"/>
+          <a:lstStyle/>
+          <a:p>
+            <a:pPr indent="0" marL="0">
+              <a:buNone/>
+            </a:pPr>
+            <a:r>
+              <a:rPr lang="en-US" sz="1000" i="1" dirty="0">
+                <a:solidFill>
+                  <a:srgbClr val="00BCD4"/>
+                </a:solidFill>
+                <a:latin typeface="Arial" pitchFamily="34" charset="0"/>
+                <a:ea typeface="Arial" pitchFamily="34" charset="-122"/>
+                <a:cs typeface="Arial" pitchFamily="34" charset="-120"/>
+              </a:rPr>
+              <a:t>"Run build.sh, then commit and push"</a:t>
+            </a:r>
+            <a:endParaRPr lang="en-US" sz="1000" dirty="0"/>
+          </a:p>
+        </p:txBody>
+      </p:sp>
+      <p:sp>
+        <p:nvSpPr>
+          <p:cNvPr id="18" name="Text 16"/>
+          <p:cNvSpPr/>
+          <p:nvPr/>
+        </p:nvSpPr>
+        <p:spPr>
+          <a:xfrm>
+            <a:off x="1371600" y="2907792"/>
+            <a:ext cx="7132320" cy="320040"/>
+          </a:xfrm>
+          <a:prstGeom prst="rect">
+            <a:avLst/>
+          </a:prstGeom>
+          <a:noFill/>
+          <a:ln/>
+        </p:spPr>
+        <p:txBody>
+          <a:bodyPr wrap="square" lIns="0" tIns="0" rIns="0" bIns="0" rtlCol="0" anchor="ctr"/>
+          <a:lstStyle/>
+          <a:p>
+            <a:pPr indent="0" marL="0">
+              <a:buNone/>
+            </a:pPr>
+            <a:r>
+              <a:rPr lang="en-US" sz="1000" dirty="0">
+                <a:solidFill>
+                  <a:srgbClr val="B0BEC5"/>
+                </a:solidFill>
+                <a:latin typeface="Arial" pitchFamily="34" charset="0"/>
+                <a:ea typeface="Arial" pitchFamily="34" charset="-122"/>
+                <a:cs typeface="Arial" pitchFamily="34" charset="-120"/>
+              </a:rPr>
+              <a:t>build.sh regenerates all plugin zips + enterprise upload folders from the updated source. git commit saves the snapshot. git push backs it up to GitHub.</a:t>
+            </a:r>
+            <a:endParaRPr lang="en-US" sz="1000" dirty="0"/>
+          </a:p>
+        </p:txBody>
+      </p:sp>
+      <p:sp>
+        <p:nvSpPr>
+          <p:cNvPr id="19" name="Shape 17"/>
+          <p:cNvSpPr/>
+          <p:nvPr/>
+        </p:nvSpPr>
+        <p:spPr>
+          <a:xfrm>
+            <a:off x="457200" y="3337560"/>
+            <a:ext cx="8321040" cy="1005840"/>
+          </a:xfrm>
+          <a:prstGeom prst="rect">
+            <a:avLst/>
+          </a:prstGeom>
+          <a:solidFill>
+            <a:srgbClr val="1E2D3D"/>
+          </a:solidFill>
+          <a:ln/>
+          <a:effectLst>
+            <a:outerShdw sx="100000" sy="100000" kx="0" ky="0" algn="bl" rotWithShape="0" blurRad="50800" dist="25400" dir="8100000">
+              <a:srgbClr val="000000">
+                <a:alpha val="30000"/>
+              </a:srgbClr>
+            </a:outerShdw>
+          </a:effectLst>
+        </p:spPr>
+      </p:sp>
+      <p:sp>
+        <p:nvSpPr>
+          <p:cNvPr id="20" name="Shape 18"/>
+          <p:cNvSpPr/>
+          <p:nvPr/>
+        </p:nvSpPr>
+        <p:spPr>
+          <a:xfrm>
+            <a:off x="457200" y="3337560"/>
+            <a:ext cx="54864" cy="1005840"/>
+          </a:xfrm>
+          <a:prstGeom prst="rect">
+            <a:avLst/>
+          </a:prstGeom>
+          <a:solidFill>
+            <a:srgbClr val="4CAF50"/>
+          </a:solidFill>
+          <a:ln/>
+        </p:spPr>
+      </p:sp>
+      <p:sp>
+        <p:nvSpPr>
+          <p:cNvPr id="21" name="Shape 19"/>
+          <p:cNvSpPr/>
+          <p:nvPr/>
+        </p:nvSpPr>
+        <p:spPr>
+          <a:xfrm>
+            <a:off x="731520" y="3474720"/>
+            <a:ext cx="457200" cy="457200"/>
+          </a:xfrm>
+          <a:prstGeom prst="ellipse">
+            <a:avLst/>
+          </a:prstGeom>
+          <a:solidFill>
+            <a:srgbClr val="4CAF50"/>
+          </a:solidFill>
+          <a:ln/>
+        </p:spPr>
+      </p:sp>
+      <p:sp>
+        <p:nvSpPr>
+          <p:cNvPr id="22" name="Text 20"/>
+          <p:cNvSpPr/>
+          <p:nvPr/>
+        </p:nvSpPr>
+        <p:spPr>
+          <a:xfrm>
+            <a:off x="731520" y="3474720"/>
+            <a:ext cx="457200" cy="457200"/>
+          </a:xfrm>
+          <a:prstGeom prst="rect">
+            <a:avLst/>
+          </a:prstGeom>
+          <a:noFill/>
+          <a:ln/>
+        </p:spPr>
+        <p:txBody>
+          <a:bodyPr wrap="square" rtlCol="0" anchor="ctr"/>
+          <a:lstStyle/>
+          <a:p>
+            <a:pPr algn="ctr" indent="0" marL="0">
+              <a:buNone/>
+            </a:pPr>
+            <a:r>
+              <a:rPr lang="en-US" sz="2200" dirty="0">
+                <a:solidFill>
+                  <a:srgbClr val="0F1B2D"/>
+                </a:solidFill>
+                <a:latin typeface="Arial Black" pitchFamily="34" charset="0"/>
+                <a:ea typeface="Arial Black" pitchFamily="34" charset="-122"/>
+                <a:cs typeface="Arial Black" pitchFamily="34" charset="-120"/>
+              </a:rPr>
+              <a:t>3</a:t>
+            </a:r>
+            <a:endParaRPr lang="en-US" sz="2200" dirty="0"/>
+          </a:p>
+        </p:txBody>
+      </p:sp>
+      <p:sp>
+        <p:nvSpPr>
+          <p:cNvPr id="23" name="Text 21"/>
+          <p:cNvSpPr/>
+          <p:nvPr/>
+        </p:nvSpPr>
+        <p:spPr>
+          <a:xfrm>
+            <a:off x="1371600" y="3429000"/>
+            <a:ext cx="7132320" cy="320040"/>
+          </a:xfrm>
+          <a:prstGeom prst="rect">
+            <a:avLst/>
+          </a:prstGeom>
+          <a:noFill/>
+          <a:ln/>
+        </p:spPr>
+        <p:txBody>
+          <a:bodyPr wrap="square" lIns="0" tIns="0" rIns="0" bIns="0" rtlCol="0" anchor="ctr"/>
+          <a:lstStyle/>
+          <a:p>
+            <a:pPr indent="0" marL="0">
+              <a:buNone/>
+            </a:pPr>
+            <a:r>
+              <a:rPr lang="en-US" sz="1600" b="1" dirty="0">
+                <a:solidFill>
+                  <a:srgbClr val="FFFFFF"/>
+                </a:solidFill>
+                <a:latin typeface="Arial" pitchFamily="34" charset="0"/>
+                <a:ea typeface="Arial" pitchFamily="34" charset="-122"/>
+                <a:cs typeface="Arial" pitchFamily="34" charset="-120"/>
+              </a:rPr>
+              <a:t>Deploy where needed</a:t>
+            </a:r>
+            <a:endParaRPr lang="en-US" sz="1600" dirty="0"/>
+          </a:p>
+        </p:txBody>
+      </p:sp>
+      <p:sp>
+        <p:nvSpPr>
+          <p:cNvPr id="24" name="Text 22"/>
+          <p:cNvSpPr/>
+          <p:nvPr/>
+        </p:nvSpPr>
+        <p:spPr>
+          <a:xfrm>
+            <a:off x="1371600" y="3749040"/>
+            <a:ext cx="7132320" cy="374904"/>
+          </a:xfrm>
+          <a:prstGeom prst="rect">
+            <a:avLst/>
+          </a:prstGeom>
+          <a:noFill/>
+          <a:ln/>
+        </p:spPr>
+        <p:txBody>
+          <a:bodyPr wrap="square" lIns="0" tIns="0" rIns="0" bIns="0" rtlCol="0" anchor="ctr"/>
+          <a:lstStyle/>
+          <a:p>
+            <a:pPr indent="0" marL="0">
+              <a:buNone/>
+            </a:pPr>
+            <a:r>
+              <a:rPr lang="en-US" sz="1000" i="1" dirty="0">
+                <a:solidFill>
+                  <a:srgbClr val="4CAF50"/>
+                </a:solidFill>
+                <a:latin typeface="Arial" pitchFamily="34" charset="0"/>
+                <a:ea typeface="Arial" pitchFamily="34" charset="-122"/>
+                <a:cs typeface="Arial" pitchFamily="34" charset="-120"/>
+              </a:rPr>
+              <a:t>Cowork: reinstall the updated plugin zip from builds/plugins-zipped/</a:t>
+            </a:r>
+            <a:endParaRPr lang="en-US" sz="1000" dirty="0"/>
+          </a:p>
+          <a:p>
+            <a:pPr indent="0" marL="0">
+              <a:buNone/>
+            </a:pPr>
+            <a:r>
+              <a:rPr lang="en-US" sz="1000" i="1" dirty="0">
+                <a:solidFill>
+                  <a:srgbClr val="4CAF50"/>
+                </a:solidFill>
+                <a:latin typeface="Arial" pitchFamily="34" charset="0"/>
+                <a:ea typeface="Arial" pitchFamily="34" charset="-122"/>
+                <a:cs typeface="Arial" pitchFamily="34" charset="-120"/>
+              </a:rPr>
+              <a:t>Enterprise: drag updated .md files from enterprise/*/upload/ into Cloud Project</a:t>
+            </a:r>
+            <a:endParaRPr lang="en-US" sz="1000" dirty="0"/>
+          </a:p>
+        </p:txBody>
+      </p:sp>
+      <p:sp>
+        <p:nvSpPr>
+          <p:cNvPr id="25" name="Text 23"/>
+          <p:cNvSpPr/>
+          <p:nvPr/>
+        </p:nvSpPr>
+        <p:spPr>
+          <a:xfrm>
+            <a:off x="1371600" y="4123944"/>
+            <a:ext cx="7132320" cy="320040"/>
+          </a:xfrm>
+          <a:prstGeom prst="rect">
+            <a:avLst/>
+          </a:prstGeom>
+          <a:noFill/>
+          <a:ln/>
+        </p:spPr>
+        <p:txBody>
+          <a:bodyPr wrap="square" lIns="0" tIns="0" rIns="0" bIns="0" rtlCol="0" anchor="ctr"/>
+          <a:lstStyle/>
+          <a:p>
+            <a:pPr indent="0" marL="0">
+              <a:buNone/>
+            </a:pPr>
+            <a:r>
+              <a:rPr lang="en-US" sz="1000" dirty="0">
+                <a:solidFill>
+                  <a:srgbClr val="B0BEC5"/>
+                </a:solidFill>
+                <a:latin typeface="Arial" pitchFamily="34" charset="0"/>
+                <a:ea typeface="Arial" pitchFamily="34" charset="-122"/>
+                <a:cs typeface="Arial" pitchFamily="34" charset="-120"/>
+              </a:rPr>
+              <a:t>Both targets now have the same updated content, built from the same source files. Nothing out of sync.</a:t>
+            </a:r>
+            <a:endParaRPr lang="en-US" sz="1000" dirty="0"/>
+          </a:p>
+        </p:txBody>
+      </p:sp>
+      <p:sp>
+        <p:nvSpPr>
+          <p:cNvPr id="26" name="Shape 24"/>
+          <p:cNvSpPr/>
+          <p:nvPr/>
+        </p:nvSpPr>
+        <p:spPr>
+          <a:xfrm>
+            <a:off x="457200" y="4434840"/>
+            <a:ext cx="8321040" cy="548640"/>
+          </a:xfrm>
+          <a:prstGeom prst="rect">
+            <a:avLst/>
+          </a:prstGeom>
+          <a:solidFill>
+            <a:srgbClr val="0D47A1"/>
+          </a:solidFill>
+          <a:ln/>
+          <a:effectLst>
+            <a:outerShdw sx="100000" sy="100000" kx="0" ky="0" algn="bl" rotWithShape="0" blurRad="50800" dist="25400" dir="8100000">
+              <a:srgbClr val="000000">
+                <a:alpha val="30000"/>
+              </a:srgbClr>
+            </a:outerShdw>
+          </a:effectLst>
+        </p:spPr>
+      </p:sp>
+      <p:sp>
+        <p:nvSpPr>
+          <p:cNvPr id="27" name="Text 25"/>
+          <p:cNvSpPr/>
+          <p:nvPr/>
+        </p:nvSpPr>
+        <p:spPr>
+          <a:xfrm>
+            <a:off x="731520" y="4462272"/>
+            <a:ext cx="7772400" cy="502920"/>
+          </a:xfrm>
+          <a:prstGeom prst="rect">
+            <a:avLst/>
+          </a:prstGeom>
+          <a:noFill/>
+          <a:ln/>
+        </p:spPr>
+        <p:txBody>
+          <a:bodyPr wrap="square" rtlCol="0" anchor="ctr"/>
+          <a:lstStyle/>
+          <a:p>
+            <a:pPr indent="0" marL="0">
+              <a:buNone/>
+            </a:pPr>
+            <a:r>
+              <a:rPr lang="en-US" sz="1400" b="1" dirty="0">
+                <a:solidFill>
+                  <a:srgbClr val="00BCD4"/>
+                </a:solidFill>
+                <a:latin typeface="Arial" pitchFamily="34" charset="0"/>
+                <a:ea typeface="Arial" pitchFamily="34" charset="-122"/>
+                <a:cs typeface="Arial" pitchFamily="34" charset="-120"/>
+              </a:rPr>
+              <a:t>That's it. </a:t>
+            </a:r>
+            <a:pPr indent="0" marL="0">
+              <a:buNone/>
+            </a:pPr>
+            <a:r>
+              <a:rPr lang="en-US" sz="1200" dirty="0">
+                <a:solidFill>
+                  <a:srgbClr val="FFFFFF"/>
+                </a:solidFill>
+                <a:latin typeface="Arial" pitchFamily="34" charset="0"/>
+                <a:ea typeface="Arial" pitchFamily="34" charset="-122"/>
+                <a:cs typeface="Arial" pitchFamily="34" charset="-120"/>
+              </a:rPr>
+              <a:t>One conversation in Claude Code handles the edit, the build, and the push. Your local folder, GitHub, plugin zips, and enterprise upload folders all stay in sync from a single source.</a:t>
+            </a:r>
+            <a:endParaRPr lang="en-US" sz="1400" dirty="0"/>
+          </a:p>
+        </p:txBody>
+      </p:sp>
+    </p:spTree>
+  </p:cSld>
+  <p:clrMapOvr>
+    <a:masterClrMapping/>
+  </p:clrMapOvr>
+</p:sld>
+</file>
+
 <file path=ppt/slides/slide2.xml><?xml version="1.0" encoding="utf-8"?>
 <p:sld xmlns:a="http://schemas.openxmlformats.org/drawingml/2006/main" xmlns:r="http://schemas.openxmlformats.org/officeDocument/2006/relationships" xmlns:p="http://schemas.openxmlformats.org/presentationml/2006/main">
   <p:cSld name="Slide 2">

</xml_diff>